<commit_message>
feat(eleva): Hyaluvita Shot volta pro catálogo da Meraki (marca única)
A pedido: produto junto com a Meraki (brand='meraki'), aparece na seção
Cosméticos & Skincare. Marca 'hyaluvita' comentada em brands.ts (fácil de
reativar) e DEFAULT_BRANDS volta a ['meraki']. Reel e capa mantidos.

Co-Authored-By: Claude Fable 5 <noreply@anthropic.com>
</commit_message>
<xml_diff>
--- a/deck-torque/Torque-ERP-Oficinas.pptx
+++ b/deck-torque/Torque-ERP-Oficinas.pptx
@@ -2988,8 +2988,8 @@
         </p:nvSpPr>
         <p:spPr>
           <a:xfrm>
-            <a:off x="548640" y="1481328"/>
-            <a:ext cx="2560320" cy="2880360"/>
+            <a:off x="548640" y="1408176"/>
+            <a:ext cx="2560320" cy="2779776"/>
           </a:xfrm>
           <a:prstGeom prst="roundRect">
             <a:avLst>
@@ -3017,7 +3017,7 @@
         </p:nvSpPr>
         <p:spPr>
           <a:xfrm>
-            <a:off x="777240" y="1645920"/>
+            <a:off x="777240" y="1572768"/>
             <a:ext cx="1280160" cy="274320"/>
           </a:xfrm>
           <a:prstGeom prst="rect">
@@ -3056,7 +3056,7 @@
         </p:nvSpPr>
         <p:spPr>
           <a:xfrm>
-            <a:off x="777240" y="1984248"/>
+            <a:off x="777240" y="1911096"/>
             <a:ext cx="2103120" cy="457200"/>
           </a:xfrm>
           <a:prstGeom prst="rect">
@@ -3109,7 +3109,7 @@
         </p:nvSpPr>
         <p:spPr>
           <a:xfrm>
-            <a:off x="777240" y="2441448"/>
+            <a:off x="777240" y="2368296"/>
             <a:ext cx="2103120" cy="219456"/>
           </a:xfrm>
           <a:prstGeom prst="rect">
@@ -3148,7 +3148,7 @@
         </p:nvSpPr>
         <p:spPr>
           <a:xfrm>
-            <a:off x="777240" y="2779776"/>
+            <a:off x="777240" y="2706624"/>
             <a:ext cx="2103120" cy="237744"/>
           </a:xfrm>
           <a:prstGeom prst="rect">
@@ -3188,7 +3188,7 @@
         </p:nvSpPr>
         <p:spPr>
           <a:xfrm>
-            <a:off x="777240" y="3054096"/>
+            <a:off x="777240" y="2980944"/>
             <a:ext cx="2103120" cy="237744"/>
           </a:xfrm>
           <a:prstGeom prst="rect">
@@ -3228,7 +3228,7 @@
         </p:nvSpPr>
         <p:spPr>
           <a:xfrm>
-            <a:off x="777240" y="3328416"/>
+            <a:off x="777240" y="3255264"/>
             <a:ext cx="2103120" cy="237744"/>
           </a:xfrm>
           <a:prstGeom prst="rect">
@@ -3268,7 +3268,7 @@
         </p:nvSpPr>
         <p:spPr>
           <a:xfrm>
-            <a:off x="777240" y="3602736"/>
+            <a:off x="777240" y="3529584"/>
             <a:ext cx="2103120" cy="237744"/>
           </a:xfrm>
           <a:prstGeom prst="rect">
@@ -3308,8 +3308,8 @@
         </p:nvSpPr>
         <p:spPr>
           <a:xfrm>
-            <a:off x="3273552" y="1371600"/>
-            <a:ext cx="2560320" cy="3108960"/>
+            <a:off x="3273552" y="1298448"/>
+            <a:ext cx="2560320" cy="2999232"/>
           </a:xfrm>
           <a:prstGeom prst="roundRect">
             <a:avLst>
@@ -3337,8 +3337,8 @@
         </p:nvSpPr>
         <p:spPr>
           <a:xfrm>
-            <a:off x="4690872" y="1554480"/>
-            <a:ext cx="960120" cy="219456"/>
+            <a:off x="4645152" y="1481328"/>
+            <a:ext cx="1005840" cy="219456"/>
           </a:xfrm>
           <a:prstGeom prst="rect">
             <a:avLst/>
@@ -3378,7 +3378,7 @@
         </p:nvSpPr>
         <p:spPr>
           <a:xfrm>
-            <a:off x="3502152" y="1536192"/>
+            <a:off x="3502152" y="1463040"/>
             <a:ext cx="1280160" cy="274320"/>
           </a:xfrm>
           <a:prstGeom prst="rect">
@@ -3417,7 +3417,7 @@
         </p:nvSpPr>
         <p:spPr>
           <a:xfrm>
-            <a:off x="3502152" y="1874520"/>
+            <a:off x="3502152" y="1801368"/>
             <a:ext cx="2103120" cy="457200"/>
           </a:xfrm>
           <a:prstGeom prst="rect">
@@ -3470,7 +3470,7 @@
         </p:nvSpPr>
         <p:spPr>
           <a:xfrm>
-            <a:off x="3502152" y="2331720"/>
+            <a:off x="3502152" y="2258568"/>
             <a:ext cx="2103120" cy="219456"/>
           </a:xfrm>
           <a:prstGeom prst="rect">
@@ -3509,7 +3509,7 @@
         </p:nvSpPr>
         <p:spPr>
           <a:xfrm>
-            <a:off x="3502152" y="2670048"/>
+            <a:off x="3502152" y="2596896"/>
             <a:ext cx="2103120" cy="237744"/>
           </a:xfrm>
           <a:prstGeom prst="rect">
@@ -3549,7 +3549,7 @@
         </p:nvSpPr>
         <p:spPr>
           <a:xfrm>
-            <a:off x="3502152" y="2944368"/>
+            <a:off x="3502152" y="2871216"/>
             <a:ext cx="2103120" cy="237744"/>
           </a:xfrm>
           <a:prstGeom prst="rect">
@@ -3589,7 +3589,7 @@
         </p:nvSpPr>
         <p:spPr>
           <a:xfrm>
-            <a:off x="3502152" y="3218688"/>
+            <a:off x="3502152" y="3145536"/>
             <a:ext cx="2103120" cy="237744"/>
           </a:xfrm>
           <a:prstGeom prst="rect">
@@ -3629,7 +3629,7 @@
         </p:nvSpPr>
         <p:spPr>
           <a:xfrm>
-            <a:off x="3502152" y="3493008"/>
+            <a:off x="3502152" y="3419856"/>
             <a:ext cx="2103120" cy="237744"/>
           </a:xfrm>
           <a:prstGeom prst="rect">
@@ -3669,7 +3669,7 @@
         </p:nvSpPr>
         <p:spPr>
           <a:xfrm>
-            <a:off x="3502152" y="3767328"/>
+            <a:off x="3502152" y="3694176"/>
             <a:ext cx="2103120" cy="237744"/>
           </a:xfrm>
           <a:prstGeom prst="rect">
@@ -3709,8 +3709,8 @@
         </p:nvSpPr>
         <p:spPr>
           <a:xfrm>
-            <a:off x="5998464" y="1481328"/>
-            <a:ext cx="2560320" cy="2880360"/>
+            <a:off x="5998464" y="1408176"/>
+            <a:ext cx="2560320" cy="2779776"/>
           </a:xfrm>
           <a:prstGeom prst="roundRect">
             <a:avLst>
@@ -3738,7 +3738,7 @@
         </p:nvSpPr>
         <p:spPr>
           <a:xfrm>
-            <a:off x="6227064" y="1645920"/>
+            <a:off x="6227064" y="1572768"/>
             <a:ext cx="1280160" cy="274320"/>
           </a:xfrm>
           <a:prstGeom prst="rect">
@@ -3777,7 +3777,7 @@
         </p:nvSpPr>
         <p:spPr>
           <a:xfrm>
-            <a:off x="6227064" y="1984248"/>
+            <a:off x="6227064" y="1911096"/>
             <a:ext cx="2103120" cy="457200"/>
           </a:xfrm>
           <a:prstGeom prst="rect">
@@ -3830,7 +3830,7 @@
         </p:nvSpPr>
         <p:spPr>
           <a:xfrm>
-            <a:off x="6227064" y="2441448"/>
+            <a:off x="6227064" y="2368296"/>
             <a:ext cx="2103120" cy="219456"/>
           </a:xfrm>
           <a:prstGeom prst="rect">
@@ -3869,7 +3869,7 @@
         </p:nvSpPr>
         <p:spPr>
           <a:xfrm>
-            <a:off x="6227064" y="2779776"/>
+            <a:off x="6227064" y="2706624"/>
             <a:ext cx="2103120" cy="237744"/>
           </a:xfrm>
           <a:prstGeom prst="rect">
@@ -3909,7 +3909,7 @@
         </p:nvSpPr>
         <p:spPr>
           <a:xfrm>
-            <a:off x="6227064" y="3054096"/>
+            <a:off x="6227064" y="2980944"/>
             <a:ext cx="2103120" cy="237744"/>
           </a:xfrm>
           <a:prstGeom prst="rect">
@@ -3949,7 +3949,7 @@
         </p:nvSpPr>
         <p:spPr>
           <a:xfrm>
-            <a:off x="6227064" y="3328416"/>
+            <a:off x="6227064" y="3255264"/>
             <a:ext cx="2103120" cy="237744"/>
           </a:xfrm>
           <a:prstGeom prst="rect">
@@ -3989,7 +3989,7 @@
         </p:nvSpPr>
         <p:spPr>
           <a:xfrm>
-            <a:off x="6227064" y="3602736"/>
+            <a:off x="6227064" y="3529584"/>
             <a:ext cx="2103120" cy="237744"/>
           </a:xfrm>
           <a:prstGeom prst="rect">
@@ -4029,8 +4029,8 @@
         </p:nvSpPr>
         <p:spPr>
           <a:xfrm>
-            <a:off x="548640" y="4645152"/>
-            <a:ext cx="8046720" cy="274320"/>
+            <a:off x="548640" y="4407408"/>
+            <a:ext cx="8046720" cy="256032"/>
           </a:xfrm>
           <a:prstGeom prst="rect">
             <a:avLst/>
@@ -4666,66 +4666,46 @@
       </p:sp>
       <p:sp>
         <p:nvSpPr>
-          <p:cNvPr id="17" name="Shape 14"/>
-          <p:cNvSpPr/>
-          <p:nvPr/>
-        </p:nvSpPr>
-        <p:spPr>
-          <a:xfrm>
-            <a:off x="5669280" y="4462272"/>
-            <a:ext cx="2926080" cy="0"/>
-          </a:xfrm>
-          <a:prstGeom prst="roundRect">
-            <a:avLst/>
-          </a:prstGeom>
-          <a:solidFill>
-            <a:srgbClr val="FFFFFF"/>
-          </a:solidFill>
-          <a:ln/>
-        </p:spPr>
+          <p:cNvPr id="17" name="Text 14"/>
+          <p:cNvSpPr/>
+          <p:nvPr/>
+        </p:nvSpPr>
+        <p:spPr>
+          <a:xfrm>
+            <a:off x="548640" y="4370832"/>
+            <a:ext cx="8046720" cy="256032"/>
+          </a:xfrm>
+          <a:prstGeom prst="rect">
+            <a:avLst/>
+          </a:prstGeom>
+          <a:noFill/>
+          <a:ln/>
+        </p:spPr>
+        <p:txBody>
+          <a:bodyPr wrap="square" lIns="0" tIns="0" rIns="0" bIns="0" rtlCol="0" anchor="ctr"/>
+          <a:lstStyle/>
+          <a:p>
+            <a:pPr indent="0" marL="0">
+              <a:buNone/>
+            </a:pPr>
+            <a:r>
+              <a:rPr lang="en-US" sz="1100" i="1" dirty="0">
+                <a:solidFill>
+                  <a:srgbClr val="F26522"/>
+                </a:solidFill>
+                <a:latin typeface="Calibri" pitchFamily="34" charset="0"/>
+                <a:ea typeface="Calibri" pitchFamily="34" charset="-122"/>
+                <a:cs typeface="Calibri" pitchFamily="34" charset="-120"/>
+              </a:rPr>
+              <a:t>ERP gruda: uma vez que a OS e o histórico do carro moram no Torque, sair custa mais que ficar.</a:t>
+            </a:r>
+            <a:endParaRPr lang="en-US" sz="1100" dirty="0"/>
+          </a:p>
+        </p:txBody>
       </p:sp>
       <p:sp>
         <p:nvSpPr>
           <p:cNvPr id="18" name="Text 15"/>
-          <p:cNvSpPr/>
-          <p:nvPr/>
-        </p:nvSpPr>
-        <p:spPr>
-          <a:xfrm>
-            <a:off x="548640" y="4443984"/>
-            <a:ext cx="8046720" cy="384048"/>
-          </a:xfrm>
-          <a:prstGeom prst="rect">
-            <a:avLst/>
-          </a:prstGeom>
-          <a:noFill/>
-          <a:ln/>
-        </p:spPr>
-        <p:txBody>
-          <a:bodyPr wrap="square" lIns="0" tIns="0" rIns="0" bIns="0" rtlCol="0" anchor="ctr"/>
-          <a:lstStyle/>
-          <a:p>
-            <a:pPr indent="0" marL="0">
-              <a:buNone/>
-            </a:pPr>
-            <a:r>
-              <a:rPr lang="en-US" sz="1100" i="1" dirty="0">
-                <a:solidFill>
-                  <a:srgbClr val="F26522"/>
-                </a:solidFill>
-                <a:latin typeface="Calibri" pitchFamily="34" charset="0"/>
-                <a:ea typeface="Calibri" pitchFamily="34" charset="-122"/>
-                <a:cs typeface="Calibri" pitchFamily="34" charset="-120"/>
-              </a:rPr>
-              <a:t>ERP gruda: uma vez que a OS e o histórico do carro moram no Torque, sair custa mais que ficar.</a:t>
-            </a:r>
-            <a:endParaRPr lang="en-US" sz="1100" dirty="0"/>
-          </a:p>
-        </p:txBody>
-      </p:sp>
-      <p:sp>
-        <p:nvSpPr>
-          <p:cNvPr id="19" name="Text 16"/>
           <p:cNvSpPr/>
           <p:nvPr/>
         </p:nvSpPr>
@@ -4764,7 +4744,7 @@
       </p:sp>
       <p:sp>
         <p:nvSpPr>
-          <p:cNvPr id="20" name="Text 17"/>
+          <p:cNvPr id="19" name="Text 16"/>
           <p:cNvSpPr/>
           <p:nvPr/>
         </p:nvSpPr>
@@ -4919,7 +4899,7 @@
         </p:nvSpPr>
         <p:spPr>
           <a:xfrm>
-            <a:off x="548640" y="1481328"/>
+            <a:off x="548640" y="1408176"/>
             <a:ext cx="3931920" cy="1298448"/>
           </a:xfrm>
           <a:prstGeom prst="roundRect">
@@ -4948,7 +4928,7 @@
         </p:nvSpPr>
         <p:spPr>
           <a:xfrm>
-            <a:off x="768096" y="1682496"/>
+            <a:off x="768096" y="1609344"/>
             <a:ext cx="457200" cy="457200"/>
           </a:xfrm>
           <a:prstGeom prst="ellipse">
@@ -4976,7 +4956,7 @@
         </p:blipFill>
         <p:spPr>
           <a:xfrm>
-            <a:off x="832104" y="1746504"/>
+            <a:off x="832104" y="1673352"/>
             <a:ext cx="329184" cy="329184"/>
           </a:xfrm>
           <a:prstGeom prst="rect">
@@ -4992,7 +4972,7 @@
         </p:nvSpPr>
         <p:spPr>
           <a:xfrm>
-            <a:off x="1371600" y="1700784"/>
+            <a:off x="1371600" y="1627632"/>
             <a:ext cx="2926080" cy="274320"/>
           </a:xfrm>
           <a:prstGeom prst="rect">
@@ -5031,7 +5011,7 @@
         </p:nvSpPr>
         <p:spPr>
           <a:xfrm>
-            <a:off x="1371600" y="2011680"/>
+            <a:off x="1371600" y="1938528"/>
             <a:ext cx="2926080" cy="640080"/>
           </a:xfrm>
           <a:prstGeom prst="rect">
@@ -5073,7 +5053,7 @@
         </p:nvSpPr>
         <p:spPr>
           <a:xfrm>
-            <a:off x="4663440" y="1481328"/>
+            <a:off x="4663440" y="1408176"/>
             <a:ext cx="3931920" cy="1298448"/>
           </a:xfrm>
           <a:prstGeom prst="roundRect">
@@ -5102,7 +5082,7 @@
         </p:nvSpPr>
         <p:spPr>
           <a:xfrm>
-            <a:off x="4882896" y="1682496"/>
+            <a:off x="4882896" y="1609344"/>
             <a:ext cx="457200" cy="457200"/>
           </a:xfrm>
           <a:prstGeom prst="ellipse">
@@ -5130,7 +5110,7 @@
         </p:blipFill>
         <p:spPr>
           <a:xfrm>
-            <a:off x="4946904" y="1746504"/>
+            <a:off x="4946904" y="1673352"/>
             <a:ext cx="329184" cy="329184"/>
           </a:xfrm>
           <a:prstGeom prst="rect">
@@ -5146,7 +5126,7 @@
         </p:nvSpPr>
         <p:spPr>
           <a:xfrm>
-            <a:off x="5486400" y="1700784"/>
+            <a:off x="5486400" y="1627632"/>
             <a:ext cx="2926080" cy="274320"/>
           </a:xfrm>
           <a:prstGeom prst="rect">
@@ -5185,7 +5165,7 @@
         </p:nvSpPr>
         <p:spPr>
           <a:xfrm>
-            <a:off x="5486400" y="2011680"/>
+            <a:off x="5486400" y="1938528"/>
             <a:ext cx="2926080" cy="640080"/>
           </a:xfrm>
           <a:prstGeom prst="rect">
@@ -5227,7 +5207,7 @@
         </p:nvSpPr>
         <p:spPr>
           <a:xfrm>
-            <a:off x="548640" y="2962656"/>
+            <a:off x="548640" y="2834640"/>
             <a:ext cx="3931920" cy="1298448"/>
           </a:xfrm>
           <a:prstGeom prst="roundRect">
@@ -5256,7 +5236,7 @@
         </p:nvSpPr>
         <p:spPr>
           <a:xfrm>
-            <a:off x="768096" y="3163824"/>
+            <a:off x="768096" y="3035808"/>
             <a:ext cx="457200" cy="457200"/>
           </a:xfrm>
           <a:prstGeom prst="ellipse">
@@ -5284,7 +5264,7 @@
         </p:blipFill>
         <p:spPr>
           <a:xfrm>
-            <a:off x="832104" y="3227832"/>
+            <a:off x="832104" y="3099816"/>
             <a:ext cx="329184" cy="329184"/>
           </a:xfrm>
           <a:prstGeom prst="rect">
@@ -5300,7 +5280,7 @@
         </p:nvSpPr>
         <p:spPr>
           <a:xfrm>
-            <a:off x="1371600" y="3182112"/>
+            <a:off x="1371600" y="3054096"/>
             <a:ext cx="2926080" cy="274320"/>
           </a:xfrm>
           <a:prstGeom prst="rect">
@@ -5339,7 +5319,7 @@
         </p:nvSpPr>
         <p:spPr>
           <a:xfrm>
-            <a:off x="1371600" y="3493008"/>
+            <a:off x="1371600" y="3364992"/>
             <a:ext cx="2926080" cy="640080"/>
           </a:xfrm>
           <a:prstGeom prst="rect">
@@ -5381,7 +5361,7 @@
         </p:nvSpPr>
         <p:spPr>
           <a:xfrm>
-            <a:off x="4663440" y="2962656"/>
+            <a:off x="4663440" y="2834640"/>
             <a:ext cx="3931920" cy="1298448"/>
           </a:xfrm>
           <a:prstGeom prst="roundRect">
@@ -5410,7 +5390,7 @@
         </p:nvSpPr>
         <p:spPr>
           <a:xfrm>
-            <a:off x="4882896" y="3163824"/>
+            <a:off x="4882896" y="3035808"/>
             <a:ext cx="457200" cy="457200"/>
           </a:xfrm>
           <a:prstGeom prst="ellipse">
@@ -5438,7 +5418,7 @@
         </p:blipFill>
         <p:spPr>
           <a:xfrm>
-            <a:off x="4946904" y="3227832"/>
+            <a:off x="4946904" y="3099816"/>
             <a:ext cx="329184" cy="329184"/>
           </a:xfrm>
           <a:prstGeom prst="rect">
@@ -5454,7 +5434,7 @@
         </p:nvSpPr>
         <p:spPr>
           <a:xfrm>
-            <a:off x="5486400" y="3182112"/>
+            <a:off x="5486400" y="3054096"/>
             <a:ext cx="2926080" cy="274320"/>
           </a:xfrm>
           <a:prstGeom prst="rect">
@@ -5493,7 +5473,7 @@
         </p:nvSpPr>
         <p:spPr>
           <a:xfrm>
-            <a:off x="5486400" y="3493008"/>
+            <a:off x="5486400" y="3364992"/>
             <a:ext cx="2926080" cy="640080"/>
           </a:xfrm>
           <a:prstGeom prst="rect">
@@ -5535,12 +5515,12 @@
         </p:nvSpPr>
         <p:spPr>
           <a:xfrm>
-            <a:off x="548640" y="4498848"/>
-            <a:ext cx="8046720" cy="457200"/>
+            <a:off x="548640" y="4224528"/>
+            <a:ext cx="8046720" cy="420624"/>
           </a:xfrm>
           <a:prstGeom prst="roundRect">
             <a:avLst>
-              <a:gd name="adj" fmla="val 14000"/>
+              <a:gd name="adj" fmla="val 15217"/>
             </a:avLst>
           </a:prstGeom>
           <a:solidFill>
@@ -5557,8 +5537,8 @@
         </p:nvSpPr>
         <p:spPr>
           <a:xfrm>
-            <a:off x="822960" y="4498848"/>
-            <a:ext cx="7498080" cy="457200"/>
+            <a:off x="822960" y="4224528"/>
+            <a:ext cx="7498080" cy="420624"/>
           </a:xfrm>
           <a:prstGeom prst="rect">
             <a:avLst/>
@@ -6189,12 +6169,12 @@
         </p:nvSpPr>
         <p:spPr>
           <a:xfrm>
-            <a:off x="5486400" y="1298448"/>
-            <a:ext cx="3108960" cy="786384"/>
+            <a:off x="5486400" y="1243584"/>
+            <a:ext cx="3108960" cy="768096"/>
           </a:xfrm>
           <a:prstGeom prst="roundRect">
             <a:avLst>
-              <a:gd name="adj" fmla="val 9302"/>
+              <a:gd name="adj" fmla="val 9524"/>
             </a:avLst>
           </a:prstGeom>
           <a:solidFill>
@@ -6218,7 +6198,7 @@
         </p:nvSpPr>
         <p:spPr>
           <a:xfrm>
-            <a:off x="5650992" y="1453896"/>
+            <a:off x="5650992" y="1389888"/>
             <a:ext cx="384048" cy="384048"/>
           </a:xfrm>
           <a:prstGeom prst="ellipse">
@@ -6246,7 +6226,7 @@
         </p:blipFill>
         <p:spPr>
           <a:xfrm>
-            <a:off x="5704759" y="1507663"/>
+            <a:off x="5704759" y="1443655"/>
             <a:ext cx="276515" cy="276515"/>
           </a:xfrm>
           <a:prstGeom prst="rect">
@@ -6262,7 +6242,7 @@
         </p:nvSpPr>
         <p:spPr>
           <a:xfrm>
-            <a:off x="6144768" y="1417320"/>
+            <a:off x="6144768" y="1353312"/>
             <a:ext cx="2331720" cy="237744"/>
           </a:xfrm>
           <a:prstGeom prst="rect">
@@ -6301,7 +6281,7 @@
         </p:nvSpPr>
         <p:spPr>
           <a:xfrm>
-            <a:off x="6144768" y="1645920"/>
+            <a:off x="6144768" y="1581912"/>
             <a:ext cx="2331720" cy="384048"/>
           </a:xfrm>
           <a:prstGeom prst="rect">
@@ -6343,12 +6323,12 @@
         </p:nvSpPr>
         <p:spPr>
           <a:xfrm>
-            <a:off x="5486400" y="2194560"/>
-            <a:ext cx="3108960" cy="786384"/>
+            <a:off x="5486400" y="2066544"/>
+            <a:ext cx="3108960" cy="768096"/>
           </a:xfrm>
           <a:prstGeom prst="roundRect">
             <a:avLst>
-              <a:gd name="adj" fmla="val 9302"/>
+              <a:gd name="adj" fmla="val 9524"/>
             </a:avLst>
           </a:prstGeom>
           <a:solidFill>
@@ -6372,7 +6352,7 @@
         </p:nvSpPr>
         <p:spPr>
           <a:xfrm>
-            <a:off x="5650992" y="2350008"/>
+            <a:off x="5650992" y="2212848"/>
             <a:ext cx="384048" cy="384048"/>
           </a:xfrm>
           <a:prstGeom prst="ellipse">
@@ -6400,7 +6380,7 @@
         </p:blipFill>
         <p:spPr>
           <a:xfrm>
-            <a:off x="5704759" y="2403775"/>
+            <a:off x="5704759" y="2266615"/>
             <a:ext cx="276515" cy="276515"/>
           </a:xfrm>
           <a:prstGeom prst="rect">
@@ -6416,7 +6396,7 @@
         </p:nvSpPr>
         <p:spPr>
           <a:xfrm>
-            <a:off x="6144768" y="2313432"/>
+            <a:off x="6144768" y="2176272"/>
             <a:ext cx="2331720" cy="237744"/>
           </a:xfrm>
           <a:prstGeom prst="rect">
@@ -6455,7 +6435,7 @@
         </p:nvSpPr>
         <p:spPr>
           <a:xfrm>
-            <a:off x="6144768" y="2542032"/>
+            <a:off x="6144768" y="2404872"/>
             <a:ext cx="2331720" cy="384048"/>
           </a:xfrm>
           <a:prstGeom prst="rect">
@@ -6497,12 +6477,12 @@
         </p:nvSpPr>
         <p:spPr>
           <a:xfrm>
-            <a:off x="5486400" y="3090672"/>
-            <a:ext cx="3108960" cy="786384"/>
+            <a:off x="5486400" y="2889504"/>
+            <a:ext cx="3108960" cy="768096"/>
           </a:xfrm>
           <a:prstGeom prst="roundRect">
             <a:avLst>
-              <a:gd name="adj" fmla="val 9302"/>
+              <a:gd name="adj" fmla="val 9524"/>
             </a:avLst>
           </a:prstGeom>
           <a:solidFill>
@@ -6526,7 +6506,7 @@
         </p:nvSpPr>
         <p:spPr>
           <a:xfrm>
-            <a:off x="5650992" y="3246120"/>
+            <a:off x="5650992" y="3035808"/>
             <a:ext cx="384048" cy="384048"/>
           </a:xfrm>
           <a:prstGeom prst="ellipse">
@@ -6554,7 +6534,7 @@
         </p:blipFill>
         <p:spPr>
           <a:xfrm>
-            <a:off x="5704759" y="3299887"/>
+            <a:off x="5704759" y="3089575"/>
             <a:ext cx="276515" cy="276515"/>
           </a:xfrm>
           <a:prstGeom prst="rect">
@@ -6570,7 +6550,7 @@
         </p:nvSpPr>
         <p:spPr>
           <a:xfrm>
-            <a:off x="6144768" y="3209544"/>
+            <a:off x="6144768" y="2999232"/>
             <a:ext cx="2331720" cy="237744"/>
           </a:xfrm>
           <a:prstGeom prst="rect">
@@ -6609,7 +6589,7 @@
         </p:nvSpPr>
         <p:spPr>
           <a:xfrm>
-            <a:off x="6144768" y="3438144"/>
+            <a:off x="6144768" y="3227832"/>
             <a:ext cx="2331720" cy="384048"/>
           </a:xfrm>
           <a:prstGeom prst="rect">
@@ -6651,12 +6631,12 @@
         </p:nvSpPr>
         <p:spPr>
           <a:xfrm>
-            <a:off x="5486400" y="3986784"/>
-            <a:ext cx="3108960" cy="786384"/>
+            <a:off x="5486400" y="3712464"/>
+            <a:ext cx="3108960" cy="768096"/>
           </a:xfrm>
           <a:prstGeom prst="roundRect">
             <a:avLst>
-              <a:gd name="adj" fmla="val 9302"/>
+              <a:gd name="adj" fmla="val 9524"/>
             </a:avLst>
           </a:prstGeom>
           <a:solidFill>
@@ -6680,7 +6660,7 @@
         </p:nvSpPr>
         <p:spPr>
           <a:xfrm>
-            <a:off x="5650992" y="4142232"/>
+            <a:off x="5650992" y="3858768"/>
             <a:ext cx="384048" cy="384048"/>
           </a:xfrm>
           <a:prstGeom prst="ellipse">
@@ -6708,7 +6688,7 @@
         </p:blipFill>
         <p:spPr>
           <a:xfrm>
-            <a:off x="5704759" y="4195999"/>
+            <a:off x="5704759" y="3912535"/>
             <a:ext cx="276515" cy="276515"/>
           </a:xfrm>
           <a:prstGeom prst="rect">
@@ -6724,7 +6704,7 @@
         </p:nvSpPr>
         <p:spPr>
           <a:xfrm>
-            <a:off x="6144768" y="4105656"/>
+            <a:off x="6144768" y="3822192"/>
             <a:ext cx="2331720" cy="237744"/>
           </a:xfrm>
           <a:prstGeom prst="rect">
@@ -6763,7 +6743,7 @@
         </p:nvSpPr>
         <p:spPr>
           <a:xfrm>
-            <a:off x="6144768" y="4334256"/>
+            <a:off x="6144768" y="4050792"/>
             <a:ext cx="2331720" cy="384048"/>
           </a:xfrm>
           <a:prstGeom prst="rect">
@@ -11128,7 +11108,7 @@
         </p:nvSpPr>
         <p:spPr>
           <a:xfrm>
-            <a:off x="548640" y="1463040"/>
+            <a:off x="548640" y="1371600"/>
             <a:ext cx="2560320" cy="1389888"/>
           </a:xfrm>
           <a:prstGeom prst="roundRect">
@@ -11157,7 +11137,7 @@
         </p:nvSpPr>
         <p:spPr>
           <a:xfrm>
-            <a:off x="749808" y="1664208"/>
+            <a:off x="749808" y="1572768"/>
             <a:ext cx="420624" cy="420624"/>
           </a:xfrm>
           <a:prstGeom prst="ellipse">
@@ -11185,7 +11165,7 @@
         </p:blipFill>
         <p:spPr>
           <a:xfrm>
-            <a:off x="808695" y="1723095"/>
+            <a:off x="808695" y="1631655"/>
             <a:ext cx="302849" cy="302849"/>
           </a:xfrm>
           <a:prstGeom prst="rect">
@@ -11201,7 +11181,7 @@
         </p:nvSpPr>
         <p:spPr>
           <a:xfrm>
-            <a:off x="1280160" y="1682496"/>
+            <a:off x="1280160" y="1591056"/>
             <a:ext cx="1691640" cy="384048"/>
           </a:xfrm>
           <a:prstGeom prst="rect">
@@ -11240,7 +11220,7 @@
         </p:nvSpPr>
         <p:spPr>
           <a:xfrm>
-            <a:off x="749808" y="2176272"/>
+            <a:off x="749808" y="2084832"/>
             <a:ext cx="2157984" cy="566928"/>
           </a:xfrm>
           <a:prstGeom prst="rect">
@@ -11282,7 +11262,7 @@
         </p:nvSpPr>
         <p:spPr>
           <a:xfrm>
-            <a:off x="3291840" y="1463040"/>
+            <a:off x="3291840" y="1371600"/>
             <a:ext cx="2560320" cy="1389888"/>
           </a:xfrm>
           <a:prstGeom prst="roundRect">
@@ -11311,7 +11291,7 @@
         </p:nvSpPr>
         <p:spPr>
           <a:xfrm>
-            <a:off x="3493008" y="1664208"/>
+            <a:off x="3493008" y="1572768"/>
             <a:ext cx="420624" cy="420624"/>
           </a:xfrm>
           <a:prstGeom prst="ellipse">
@@ -11339,7 +11319,7 @@
         </p:blipFill>
         <p:spPr>
           <a:xfrm>
-            <a:off x="3551895" y="1723095"/>
+            <a:off x="3551895" y="1631655"/>
             <a:ext cx="302849" cy="302849"/>
           </a:xfrm>
           <a:prstGeom prst="rect">
@@ -11355,7 +11335,7 @@
         </p:nvSpPr>
         <p:spPr>
           <a:xfrm>
-            <a:off x="4023360" y="1682496"/>
+            <a:off x="4023360" y="1591056"/>
             <a:ext cx="1691640" cy="384048"/>
           </a:xfrm>
           <a:prstGeom prst="rect">
@@ -11394,7 +11374,7 @@
         </p:nvSpPr>
         <p:spPr>
           <a:xfrm>
-            <a:off x="3493008" y="2176272"/>
+            <a:off x="3493008" y="2084832"/>
             <a:ext cx="2157984" cy="566928"/>
           </a:xfrm>
           <a:prstGeom prst="rect">
@@ -11436,7 +11416,7 @@
         </p:nvSpPr>
         <p:spPr>
           <a:xfrm>
-            <a:off x="6035040" y="1463040"/>
+            <a:off x="6035040" y="1371600"/>
             <a:ext cx="2560320" cy="1389888"/>
           </a:xfrm>
           <a:prstGeom prst="roundRect">
@@ -11465,7 +11445,7 @@
         </p:nvSpPr>
         <p:spPr>
           <a:xfrm>
-            <a:off x="6236208" y="1664208"/>
+            <a:off x="6236208" y="1572768"/>
             <a:ext cx="420624" cy="420624"/>
           </a:xfrm>
           <a:prstGeom prst="ellipse">
@@ -11493,7 +11473,7 @@
         </p:blipFill>
         <p:spPr>
           <a:xfrm>
-            <a:off x="6295095" y="1723095"/>
+            <a:off x="6295095" y="1631655"/>
             <a:ext cx="302849" cy="302849"/>
           </a:xfrm>
           <a:prstGeom prst="rect">
@@ -11509,7 +11489,7 @@
         </p:nvSpPr>
         <p:spPr>
           <a:xfrm>
-            <a:off x="6766560" y="1682496"/>
+            <a:off x="6766560" y="1591056"/>
             <a:ext cx="1691640" cy="384048"/>
           </a:xfrm>
           <a:prstGeom prst="rect">
@@ -11548,7 +11528,7 @@
         </p:nvSpPr>
         <p:spPr>
           <a:xfrm>
-            <a:off x="6236208" y="2176272"/>
+            <a:off x="6236208" y="2084832"/>
             <a:ext cx="2157984" cy="566928"/>
           </a:xfrm>
           <a:prstGeom prst="rect">
@@ -11590,7 +11570,7 @@
         </p:nvSpPr>
         <p:spPr>
           <a:xfrm>
-            <a:off x="548640" y="3035808"/>
+            <a:off x="548640" y="2889504"/>
             <a:ext cx="2560320" cy="1389888"/>
           </a:xfrm>
           <a:prstGeom prst="roundRect">
@@ -11619,7 +11599,7 @@
         </p:nvSpPr>
         <p:spPr>
           <a:xfrm>
-            <a:off x="749808" y="3236976"/>
+            <a:off x="749808" y="3090672"/>
             <a:ext cx="420624" cy="420624"/>
           </a:xfrm>
           <a:prstGeom prst="ellipse">
@@ -11647,7 +11627,7 @@
         </p:blipFill>
         <p:spPr>
           <a:xfrm>
-            <a:off x="808695" y="3295863"/>
+            <a:off x="808695" y="3149559"/>
             <a:ext cx="302849" cy="302849"/>
           </a:xfrm>
           <a:prstGeom prst="rect">
@@ -11663,7 +11643,7 @@
         </p:nvSpPr>
         <p:spPr>
           <a:xfrm>
-            <a:off x="1280160" y="3255264"/>
+            <a:off x="1280160" y="3108960"/>
             <a:ext cx="1691640" cy="384048"/>
           </a:xfrm>
           <a:prstGeom prst="rect">
@@ -11702,7 +11682,7 @@
         </p:nvSpPr>
         <p:spPr>
           <a:xfrm>
-            <a:off x="749808" y="3749040"/>
+            <a:off x="749808" y="3602736"/>
             <a:ext cx="2157984" cy="566928"/>
           </a:xfrm>
           <a:prstGeom prst="rect">
@@ -11744,7 +11724,7 @@
         </p:nvSpPr>
         <p:spPr>
           <a:xfrm>
-            <a:off x="3291840" y="3035808"/>
+            <a:off x="3291840" y="2889504"/>
             <a:ext cx="2560320" cy="1389888"/>
           </a:xfrm>
           <a:prstGeom prst="roundRect">
@@ -11773,7 +11753,7 @@
         </p:nvSpPr>
         <p:spPr>
           <a:xfrm>
-            <a:off x="3493008" y="3236976"/>
+            <a:off x="3493008" y="3090672"/>
             <a:ext cx="420624" cy="420624"/>
           </a:xfrm>
           <a:prstGeom prst="ellipse">
@@ -11801,7 +11781,7 @@
         </p:blipFill>
         <p:spPr>
           <a:xfrm>
-            <a:off x="3551895" y="3295863"/>
+            <a:off x="3551895" y="3149559"/>
             <a:ext cx="302849" cy="302849"/>
           </a:xfrm>
           <a:prstGeom prst="rect">
@@ -11817,7 +11797,7 @@
         </p:nvSpPr>
         <p:spPr>
           <a:xfrm>
-            <a:off x="4023360" y="3255264"/>
+            <a:off x="4023360" y="3108960"/>
             <a:ext cx="1691640" cy="384048"/>
           </a:xfrm>
           <a:prstGeom prst="rect">
@@ -11856,7 +11836,7 @@
         </p:nvSpPr>
         <p:spPr>
           <a:xfrm>
-            <a:off x="3493008" y="3749040"/>
+            <a:off x="3493008" y="3602736"/>
             <a:ext cx="2157984" cy="566928"/>
           </a:xfrm>
           <a:prstGeom prst="rect">
@@ -11898,7 +11878,7 @@
         </p:nvSpPr>
         <p:spPr>
           <a:xfrm>
-            <a:off x="6035040" y="3035808"/>
+            <a:off x="6035040" y="2889504"/>
             <a:ext cx="2560320" cy="1389888"/>
           </a:xfrm>
           <a:prstGeom prst="roundRect">
@@ -11927,7 +11907,7 @@
         </p:nvSpPr>
         <p:spPr>
           <a:xfrm>
-            <a:off x="6236208" y="3236976"/>
+            <a:off x="6236208" y="3090672"/>
             <a:ext cx="420624" cy="420624"/>
           </a:xfrm>
           <a:prstGeom prst="ellipse">
@@ -11955,7 +11935,7 @@
         </p:blipFill>
         <p:spPr>
           <a:xfrm>
-            <a:off x="6295095" y="3295863"/>
+            <a:off x="6295095" y="3149559"/>
             <a:ext cx="302849" cy="302849"/>
           </a:xfrm>
           <a:prstGeom prst="rect">
@@ -11971,7 +11951,7 @@
         </p:nvSpPr>
         <p:spPr>
           <a:xfrm>
-            <a:off x="6766560" y="3255264"/>
+            <a:off x="6766560" y="3108960"/>
             <a:ext cx="1691640" cy="384048"/>
           </a:xfrm>
           <a:prstGeom prst="rect">
@@ -12010,7 +11990,7 @@
         </p:nvSpPr>
         <p:spPr>
           <a:xfrm>
-            <a:off x="6236208" y="3749040"/>
+            <a:off x="6236208" y="3602736"/>
             <a:ext cx="2157984" cy="566928"/>
           </a:xfrm>
           <a:prstGeom prst="rect">
@@ -12052,8 +12032,8 @@
         </p:nvSpPr>
         <p:spPr>
           <a:xfrm>
-            <a:off x="548640" y="4626864"/>
-            <a:ext cx="6858000" cy="274320"/>
+            <a:off x="548640" y="4370832"/>
+            <a:ext cx="6858000" cy="256032"/>
           </a:xfrm>
           <a:prstGeom prst="rect">
             <a:avLst/>
@@ -13281,8 +13261,8 @@
         </p:nvSpPr>
         <p:spPr>
           <a:xfrm>
-            <a:off x="457200" y="4462272"/>
-            <a:ext cx="4937760" cy="237744"/>
+            <a:off x="457200" y="4389120"/>
+            <a:ext cx="4937760" cy="219456"/>
           </a:xfrm>
           <a:prstGeom prst="rect">
             <a:avLst/>

</xml_diff>